<commit_message>
feat: Enhance agent functionality with deduplication tracking and grading snapshots
- Added new fields in AgentState to track documents removed and kept during deduplication.
- Implemented logic to capture and return deduplication pairs in retrieval processes.
- Updated retrieval functions to support deduplication tracking and improved document handling.
- Enhanced grading process to include snapshots before rewrites, ensuring consistency in evaluations.
- Modified deduplication evaluation to compare removed and kept documents directly, measuring real information loss.
- Improved evaluation metrics for query rewriting to assess targeting effectiveness of new queries.
- Updated relevant prompts and evaluation functions to accommodate new deduplication and grading features.
</commit_message>
<xml_diff>
--- a/Presentation_RAG_Aquila.pptx
+++ b/Presentation_RAG_Aquila.pptx
@@ -15296,7 +15296,7 @@
                 </a:solidFill>
                 <a:latin typeface="Segoe UI"/>
               </a:rPr>
-              <a:t>evaluate_components.py — isoler et mesurer chacune des 6 briques du pipeline agentique</a:t>
+              <a:t>evaluate_components.py — isoler et mesurer chacune des 8 briques du pipeline agentique</a:t>
             </a:r>
           </a:p>
         </p:txBody>
@@ -15351,7 +15351,7 @@
                 </a:solidFill>
                 <a:latin typeface="Segoe UI Semibold"/>
               </a:rPr>
-              <a:t>6 Briques Évaluées</a:t>
+              <a:t>8 Briques Évaluées</a:t>
             </a:r>
           </a:p>
         </p:txBody>
@@ -16793,7 +16793,7 @@
                 </a:solidFill>
                 <a:latin typeface="Segoe UI Semibold"/>
               </a:rPr>
-              <a:t>6 briques évaluées indépendamment</a:t>
+              <a:t>8 briques évaluées indépendamment</a:t>
             </a:r>
           </a:p>
           <a:p>
@@ -16805,7 +16805,7 @@
                 </a:solidFill>
                 <a:latin typeface="Segoe UI"/>
               </a:rPr>
-              <a:t>① Router ② Retrieval ③ Re-ranking ④ Grading ⑤ Rewriting ⑥ Generation</a:t>
+              <a:t>① Router ② Retrieval ③ Re-ranking ④ Grading ⑤ Rewriting ⑥ Generation ⑦ Déduplication ⑧ Fusion RRF</a:t>
             </a:r>
           </a:p>
         </p:txBody>
@@ -22652,7 +22652,7 @@
                 </a:solidFill>
                 <a:latin typeface="Segoe UI Semibold"/>
               </a:rPr>
-              <a:t>Briques ④⑤⑥</a:t>
+              <a:t>Briques ④⑤⑥⑦⑧</a:t>
             </a:r>
           </a:p>
         </p:txBody>
@@ -22691,7 +22691,7 @@
                 </a:solidFill>
                 <a:latin typeface="Segoe UI"/>
               </a:rPr>
-              <a:t>Grading (matrice de confusion), Rewriting, Generation</a:t>
+              <a:t>Grading, Rewriting, Generation, Déduplication, Fusion RRF</a:t>
             </a:r>
           </a:p>
         </p:txBody>
@@ -23841,7 +23841,7 @@
                 </a:solidFill>
                 <a:latin typeface="Segoe UI"/>
               </a:rPr>
-              <a:t>eval_retrieval_and_reranking() — RAGAS ContextPrecision/Recall, gemma2:2b</a:t>
+              <a:t>eval_retrieval_and_reranking() — RAGAS ContextPrecision/Recall + NDCG + MRR (LLM-juge), gemma2:2b</a:t>
             </a:r>
           </a:p>
         </p:txBody>
@@ -24433,7 +24433,7 @@
                 <a:latin typeface="Segoe UI"/>
               </a:rPr>
               <a:t>RAGAS Precision+Recall
-sur pre_rerank_docs</a:t>
++ NDCG/MRR sur pre_rerank_docs</a:t>
             </a:r>
           </a:p>
         </p:txBody>
@@ -24503,7 +24503,7 @@
                 <a:latin typeface="Segoe UI"/>
               </a:rPr>
               <a:t>RAGAS Precision+Recall
-sur post_rerank_docs</a:t>
++ NDCG/MRR sur post_rerank_docs</a:t>
             </a:r>
           </a:p>
         </p:txBody>
@@ -24783,7 +24783,7 @@
                 </a:solidFill>
                 <a:latin typeface="Segoe UI"/>
               </a:rPr>
-              <a:t>ContextPrecision : le LLM juge chaque chunk pertinent vis-à-vis de la réponse, pondéré par rang. ContextRecall : la réponse est découpée en affirmations, chacune doit être attribuable à un chunk.</a:t>
+              <a:t>ContextPrecision : le LLM juge chaque chunk pertinent vis-à-vis de la réponse, pondéré par rang. ContextRecall : la réponse est découpée en affirmations, chacune doit être attribuable à un chunk. NDCG/MRR : un LLM-juge labellise chaque chunk pertinent/non pertinent pour mesurer la qualité du classement avant/après re-ranking.</a:t>
             </a:r>
           </a:p>
         </p:txBody>
@@ -27235,7 +27235,7 @@
                 </a:solidFill>
                 <a:latin typeface="Segoe UI"/>
               </a:rPr>
-              <a:t>eval_rewriting() — gain RAGAS (Precision+Recall), gemma2:2b — si rewrite déclenché</a:t>
+              <a:t>eval_rewriting() — gain RAGAS + taux de réussite + chunks utiles, gemma2:2b — si rewrite déclenché</a:t>
             </a:r>
           </a:p>
         </p:txBody>
@@ -28156,6 +28156,34 @@
                 <a:latin typeface="Segoe UI"/>
               </a:rPr>
               <a:t>Le pool « après » est exactement celui produit par le vrai pipeline, pas reconstruit artificiellement</a:t>
+            </a:r>
+          </a:p>
+          <a:p>
+            <a:pPr>
+              <a:lnSpc>
+                <a:spcPct val="108000"/>
+              </a:lnSpc>
+              <a:spcAft>
+                <a:spcPts val="400"/>
+              </a:spcAft>
+            </a:pPr>
+            <a:r>
+              <a:rPr sz="930" b="1">
+                <a:solidFill>
+                  <a:srgbClr val="8A5CF6"/>
+                </a:solidFill>
+                <a:latin typeface="Segoe UI"/>
+              </a:rPr>
+              <a:t>—  </a:t>
+            </a:r>
+            <a:r>
+              <a:rPr sz="930">
+                <a:solidFill>
+                  <a:srgbClr val="1B1F27"/>
+                </a:solidFill>
+                <a:latin typeface="Segoe UI"/>
+              </a:rPr>
+              <a:t>—  Taux de réussite (rewrite_success) : le grading final dit-il OUI après rewrite ? Et nouveaux chunks utiles (rewrite_new_ratio) : part des chunks apportés par la reformulation jugés pertinents par le LLM-juge</a:t>
             </a:r>
           </a:p>
         </p:txBody>
@@ -37382,7 +37410,7 @@
                 </a:solidFill>
                 <a:latin typeface="Segoe UI"/>
               </a:rPr>
-              <a:t>evaluate_components.py : 2 à 8 appels gemma2:2b (RAGAS) par question + 1 appel gemma4:12b pour le juge de grading (si difficulté &gt; 1)</a:t>
+              <a:t>evaluate_components.py : 15 à 40 appels gemma2:2b (RAGAS + LLM-juge NDCG/MRR/dédup/RRF) par question + 1 appel gemma4:12b pour le juge de grading (si difficulté &gt; 1)</a:t>
             </a:r>
           </a:p>
           <a:p>
@@ -37410,7 +37438,35 @@
                 </a:solidFill>
                 <a:latin typeface="Segoe UI"/>
               </a:rPr>
-              <a:t>Total scoring estimé : ~200 à 400 appels LLM pour les 50 questions</a:t>
+              <a:t>Total scoring estimé : ~750 à 2000 appels LLM pour les 50 questions</a:t>
+            </a:r>
+          </a:p>
+          <a:p>
+            <a:pPr>
+              <a:lnSpc>
+                <a:spcPct val="108000"/>
+              </a:lnSpc>
+              <a:spcAft>
+                <a:spcPts val="400"/>
+              </a:spcAft>
+            </a:pPr>
+            <a:r>
+              <a:rPr sz="1050" b="1">
+                <a:solidFill>
+                  <a:srgbClr val="3A86FF"/>
+                </a:solidFill>
+                <a:latin typeface="Segoe UI"/>
+              </a:rPr>
+              <a:t>—  </a:t>
+            </a:r>
+            <a:r>
+              <a:rPr sz="1050">
+                <a:solidFill>
+                  <a:srgbClr val="1B1F27"/>
+                </a:solidFill>
+                <a:latin typeface="Segoe UI"/>
+              </a:rPr>
+              <a:t>—  Briques ⑦⑧ nécessitent un re-run de run_agentic_all.py (champs pre_dedup_docs / semantic_docs / bm25_docs absents des anciens résultats)</a:t>
             </a:r>
           </a:p>
         </p:txBody>
@@ -45168,7 +45224,7 @@
                 </a:solidFill>
                 <a:latin typeface="Segoe UI"/>
               </a:rPr>
-              <a:t>▸ evaluate_components.py — 6 briques (relit le debug)</a:t>
+              <a:t>▸ evaluate_components.py — 8 briques (relit le debug)</a:t>
             </a:r>
           </a:p>
         </p:txBody>

</xml_diff>

<commit_message>
feat: Update diagram configurations with font size and flowchart settings
</commit_message>
<xml_diff>
--- a/Presentation_RAG_Aquila.pptx
+++ b/Presentation_RAG_Aquila.pptx
@@ -27237,27 +27237,105 @@
                 </a:solidFill>
                 <a:latin typeface="Segoe UI"/>
               </a:rPr>
-              <a:t>eval_rewriting() — gain RAGAS + taux de réussite + chunks utiles + ciblage, gemma2:2b — si rewrite déclenché</a:t>
-            </a:r>
-          </a:p>
-        </p:txBody>
-      </p:sp>
-      <p:sp>
-        <p:nvSpPr>
-          <p:cNvPr id="6" name="Diamond 5"/>
+              <a:t>eval_rewriting() — 3 angles de mesure, gemma2:2b — si rewrite déclenché (grading initial = NON)</a:t>
+            </a:r>
+          </a:p>
+        </p:txBody>
+      </p:sp>
+      <p:sp>
+        <p:nvSpPr>
+          <p:cNvPr id="24" name="TextBox 23"/>
+          <p:cNvSpPr txBox="1"/>
+          <p:nvPr/>
+        </p:nvSpPr>
+        <p:spPr>
+          <a:xfrm>
+            <a:off x="502920" y="6547104"/>
+            <a:ext cx="3657600" cy="274320"/>
+          </a:xfrm>
+          <a:prstGeom prst="rect">
+            <a:avLst/>
+          </a:prstGeom>
+          <a:noFill/>
+        </p:spPr>
+        <p:txBody>
+          <a:bodyPr wrap="square" anchor="t" lIns="0" rIns="0" tIns="0" bIns="0">
+            <a:spAutoFit/>
+          </a:bodyPr>
+          <a:lstStyle/>
+          <a:p>
+            <a:pPr algn="l">
+              <a:lnSpc>
+                <a:spcPct val="100000"/>
+              </a:lnSpc>
+            </a:pPr>
+            <a:r>
+              <a:rPr sz="900" b="0" i="0">
+                <a:solidFill>
+                  <a:srgbClr val="5B6677"/>
+                </a:solidFill>
+                <a:latin typeface="Segoe UI"/>
+              </a:rPr>
+              <a:t>RAG Aquila — Système RAG Agentique</a:t>
+            </a:r>
+          </a:p>
+        </p:txBody>
+      </p:sp>
+      <p:sp>
+        <p:nvSpPr>
+          <p:cNvPr id="25" name="TextBox 24"/>
+          <p:cNvSpPr txBox="1"/>
+          <p:nvPr/>
+        </p:nvSpPr>
+        <p:spPr>
+          <a:xfrm>
+            <a:off x="10972800" y="6547104"/>
+            <a:ext cx="731520" cy="274320"/>
+          </a:xfrm>
+          <a:prstGeom prst="rect">
+            <a:avLst/>
+          </a:prstGeom>
+          <a:noFill/>
+        </p:spPr>
+        <p:txBody>
+          <a:bodyPr wrap="square" anchor="t" lIns="0" rIns="0" tIns="0" bIns="0">
+            <a:spAutoFit/>
+          </a:bodyPr>
+          <a:lstStyle/>
+          <a:p>
+            <a:pPr algn="r">
+              <a:lnSpc>
+                <a:spcPct val="100000"/>
+              </a:lnSpc>
+            </a:pPr>
+            <a:r>
+              <a:rPr sz="900" b="0" i="0">
+                <a:solidFill>
+                  <a:srgbClr val="5B6677"/>
+                </a:solidFill>
+                <a:latin typeface="Segoe UI"/>
+              </a:rPr>
+              <a:t>22/32</a:t>
+            </a:r>
+          </a:p>
+        </p:txBody>
+      </p:sp>
+      <p:sp>
+        <p:nvSpPr>
+          <p:cNvPr id="26" name="Rectangle 25"/>
           <p:cNvSpPr/>
           <p:nvPr/>
         </p:nvSpPr>
         <p:spPr>
           <a:xfrm>
-            <a:off x="502920" y="1280160"/>
-            <a:ext cx="3108960" cy="1005840"/>
-          </a:xfrm>
-          <a:prstGeom prst="diamond">
+            <a:off x="0" y="6492240"/>
+            <a:ext cx="12191695" cy="9525"/>
+          </a:xfrm>
+          <a:prstGeom prst="rect">
             <a:avLst/>
           </a:prstGeom>
           <a:solidFill>
-            <a:srgbClr val="0B1F3A"/>
+            <a:srgbClr val="E3E8EE"/>
           </a:solidFill>
           <a:ln>
             <a:noFill/>
@@ -27279,661 +27357,23 @@
           </a:fontRef>
         </p:style>
         <p:txBody>
-          <a:bodyPr rtlCol="0" anchor="ctr" wrap="square" lIns="25400" rIns="25400" tIns="0" bIns="0"/>
+          <a:bodyPr rtlCol="0" anchor="ctr"/>
           <a:lstStyle/>
           <a:p>
             <a:pPr algn="ctr"/>
-            <a:r>
-              <a:rPr sz="1000" b="1">
-                <a:solidFill>
-                  <a:srgbClr val="FFFFFF"/>
-                </a:solidFill>
-                <a:latin typeface="Segoe UI Semibold"/>
-              </a:rPr>
-              <a:t>rewrite['triggered']
-Déclenché pour cette question ?</a:t>
-            </a:r>
-          </a:p>
-        </p:txBody>
-      </p:sp>
-      <p:cxnSp>
-        <p:nvCxnSpPr>
-          <p:cNvPr id="7" name="Connector 6"/>
-          <p:cNvCxnSpPr/>
-          <p:nvPr/>
-        </p:nvCxnSpPr>
-        <p:spPr>
-          <a:xfrm>
-            <a:off x="2057400" y="2286000"/>
-            <a:ext cx="0" cy="320040"/>
-          </a:xfrm>
-          <a:prstGeom prst="line">
-            <a:avLst/>
-          </a:prstGeom>
-          <a:ln w="28575">
-            <a:solidFill>
-              <a:srgbClr val="E64A4A"/>
-            </a:solidFill>
-            <a:tailEnd type="triangle" w="med" len="med"/>
-          </a:ln>
-          <a:effectLst/>
-        </p:spPr>
-        <p:style>
-          <a:lnRef idx="2">
-            <a:schemeClr val="accent1"/>
-          </a:lnRef>
-          <a:fillRef idx="0">
-            <a:schemeClr val="accent1"/>
-          </a:fillRef>
-          <a:effectRef idx="1">
-            <a:schemeClr val="accent1"/>
-          </a:effectRef>
-          <a:fontRef idx="minor">
-            <a:schemeClr val="tx1"/>
-          </a:fontRef>
-        </p:style>
-      </p:cxnSp>
-      <p:sp>
-        <p:nvSpPr>
-          <p:cNvPr id="8" name="TextBox 7"/>
-          <p:cNvSpPr txBox="1"/>
-          <p:nvPr/>
-        </p:nvSpPr>
-        <p:spPr>
-          <a:xfrm>
-            <a:off x="2103120" y="2304288"/>
-            <a:ext cx="1920240" cy="274320"/>
-          </a:xfrm>
-          <a:prstGeom prst="rect">
-            <a:avLst/>
-          </a:prstGeom>
-          <a:noFill/>
-        </p:spPr>
-        <p:txBody>
-          <a:bodyPr wrap="square" anchor="t" lIns="0" rIns="0" tIns="0" bIns="0">
-            <a:spAutoFit/>
-          </a:bodyPr>
-          <a:lstStyle/>
-          <a:p>
-            <a:pPr algn="l">
-              <a:lnSpc>
-                <a:spcPct val="95000"/>
-              </a:lnSpc>
-            </a:pPr>
-            <a:r>
-              <a:rPr sz="730" b="0" i="1">
-                <a:solidFill>
-                  <a:srgbClr val="E64A4A"/>
-                </a:solidFill>
-                <a:latin typeface="Segoe UI"/>
-              </a:rPr>
-              <a:t>NON → grading OUI / diff=1</a:t>
-            </a:r>
-          </a:p>
-        </p:txBody>
-      </p:sp>
-      <p:sp>
-        <p:nvSpPr>
-          <p:cNvPr id="9" name="Rounded Rectangle 8"/>
+          </a:p>
+        </p:txBody>
+      </p:sp>
+      <p:sp>
+        <p:nvSpPr>
+          <p:cNvPr id="27" name="Rounded Rectangle 19"/>
           <p:cNvSpPr/>
           <p:nvPr/>
         </p:nvSpPr>
         <p:spPr>
           <a:xfrm>
-            <a:off x="502920" y="2606040"/>
-            <a:ext cx="3108960" cy="548640"/>
-          </a:xfrm>
-          <a:prstGeom prst="roundRect">
-            <a:avLst>
-              <a:gd name="adj" fmla="val 10000"/>
-            </a:avLst>
-          </a:prstGeom>
-          <a:solidFill>
-            <a:srgbClr val="FFFFFF"/>
-          </a:solidFill>
-          <a:ln w="22225">
-            <a:solidFill>
-              <a:srgbClr val="5B6677"/>
-            </a:solidFill>
-          </a:ln>
-          <a:effectLst/>
-        </p:spPr>
-        <p:style>
-          <a:lnRef idx="1">
-            <a:schemeClr val="accent1"/>
-          </a:lnRef>
-          <a:fillRef idx="3">
-            <a:schemeClr val="accent1"/>
-          </a:fillRef>
-          <a:effectRef idx="2">
-            <a:schemeClr val="accent1"/>
-          </a:effectRef>
-          <a:fontRef idx="minor">
-            <a:schemeClr val="lt1"/>
-          </a:fontRef>
-        </p:style>
-        <p:txBody>
-          <a:bodyPr rtlCol="0" anchor="ctr" wrap="square" lIns="101600" rIns="101600" tIns="50800" bIns="50800"/>
-          <a:lstStyle/>
-          <a:p>
-            <a:pPr algn="ctr"/>
-            <a:r>
-              <a:rPr sz="1000" b="1">
-                <a:solidFill>
-                  <a:srgbClr val="0B1F3A"/>
-                </a:solidFill>
-                <a:latin typeface="Segoe UI Semibold"/>
-              </a:rPr>
-              <a:t>Résultat : N/A</a:t>
-            </a:r>
-          </a:p>
-          <a:p>
-            <a:pPr algn="ctr"/>
-            <a:r>
-              <a:rPr sz="800">
-                <a:solidFill>
-                  <a:srgbClr val="5B6677"/>
-                </a:solidFill>
-                <a:latin typeface="Segoe UI"/>
-              </a:rPr>
-              <a:t>rewrite_triggered = 0, exclu des moyennes</a:t>
-            </a:r>
-          </a:p>
-        </p:txBody>
-      </p:sp>
-      <p:sp>
-        <p:nvSpPr>
-          <p:cNvPr id="10" name="TextBox 9"/>
-          <p:cNvSpPr txBox="1"/>
-          <p:nvPr/>
-        </p:nvSpPr>
-        <p:spPr>
-          <a:xfrm>
-            <a:off x="4023360" y="1280160"/>
-            <a:ext cx="7680960" cy="274320"/>
-          </a:xfrm>
-          <a:prstGeom prst="rect">
-            <a:avLst/>
-          </a:prstGeom>
-          <a:noFill/>
-        </p:spPr>
-        <p:txBody>
-          <a:bodyPr wrap="square" anchor="t" lIns="0" rIns="0" tIns="0" bIns="0">
-            <a:spAutoFit/>
-          </a:bodyPr>
-          <a:lstStyle/>
-          <a:p>
-            <a:pPr algn="l">
-              <a:lnSpc>
-                <a:spcPct val="100000"/>
-              </a:lnSpc>
-            </a:pPr>
-            <a:r>
-              <a:rPr sz="1250" b="1" i="0">
-                <a:solidFill>
-                  <a:srgbClr val="0B1F3A"/>
-                </a:solidFill>
-                <a:latin typeface="Segoe UI Semibold"/>
-              </a:rPr>
-              <a:t>Mesure du gain apporté par la reformulation</a:t>
-            </a:r>
-          </a:p>
-        </p:txBody>
-      </p:sp>
-      <p:sp>
-        <p:nvSpPr>
-          <p:cNvPr id="11" name="Rounded Rectangle 10"/>
-          <p:cNvSpPr/>
-          <p:nvPr/>
-        </p:nvSpPr>
-        <p:spPr>
-          <a:xfrm>
-            <a:off x="4023360" y="1645920"/>
-            <a:ext cx="3657600" cy="868680"/>
-          </a:xfrm>
-          <a:prstGeom prst="roundRect">
-            <a:avLst>
-              <a:gd name="adj" fmla="val 10000"/>
-            </a:avLst>
-          </a:prstGeom>
-          <a:solidFill>
-            <a:srgbClr val="FFFFFF"/>
-          </a:solidFill>
-          <a:ln w="22225">
-            <a:solidFill>
-              <a:srgbClr val="3A86FF"/>
-            </a:solidFill>
-          </a:ln>
-          <a:effectLst/>
-        </p:spPr>
-        <p:style>
-          <a:lnRef idx="1">
-            <a:schemeClr val="accent1"/>
-          </a:lnRef>
-          <a:fillRef idx="3">
-            <a:schemeClr val="accent1"/>
-          </a:fillRef>
-          <a:effectRef idx="2">
-            <a:schemeClr val="accent1"/>
-          </a:effectRef>
-          <a:fontRef idx="minor">
-            <a:schemeClr val="lt1"/>
-          </a:fontRef>
-        </p:style>
-        <p:txBody>
-          <a:bodyPr rtlCol="0" anchor="ctr" wrap="square" lIns="101600" rIns="101600" tIns="50800" bIns="50800"/>
-          <a:lstStyle/>
-          <a:p>
-            <a:pPr algn="ctr"/>
-            <a:r>
-              <a:rPr sz="1050" b="1">
-                <a:solidFill>
-                  <a:srgbClr val="0B1F3A"/>
-                </a:solidFill>
-                <a:latin typeface="Segoe UI Semibold"/>
-              </a:rPr>
-              <a:t>Baseline (avant rewrite)</a:t>
-            </a:r>
-          </a:p>
-          <a:p>
-            <a:pPr algn="ctr"/>
-            <a:r>
-              <a:rPr sz="850">
-                <a:solidFill>
-                  <a:srgbClr val="5B6677"/>
-                </a:solidFill>
-                <a:latin typeface="Segoe UI"/>
-              </a:rPr>
-              <a:t>Scores réutilisés depuis la brique ②
-Pas de 2ᵉ appel LLM</a:t>
-            </a:r>
-          </a:p>
-        </p:txBody>
-      </p:sp>
-      <p:sp>
-        <p:nvSpPr>
-          <p:cNvPr id="12" name="Rounded Rectangle 11"/>
-          <p:cNvSpPr/>
-          <p:nvPr/>
-        </p:nvSpPr>
-        <p:spPr>
-          <a:xfrm>
-            <a:off x="7955279" y="1645920"/>
-            <a:ext cx="3703320" cy="868680"/>
-          </a:xfrm>
-          <a:prstGeom prst="roundRect">
-            <a:avLst>
-              <a:gd name="adj" fmla="val 10000"/>
-            </a:avLst>
-          </a:prstGeom>
-          <a:solidFill>
-            <a:srgbClr val="FFFFFF"/>
-          </a:solidFill>
-          <a:ln w="22225">
-            <a:solidFill>
-              <a:srgbClr val="2EA86A"/>
-            </a:solidFill>
-          </a:ln>
-          <a:effectLst/>
-        </p:spPr>
-        <p:style>
-          <a:lnRef idx="1">
-            <a:schemeClr val="accent1"/>
-          </a:lnRef>
-          <a:fillRef idx="3">
-            <a:schemeClr val="accent1"/>
-          </a:fillRef>
-          <a:effectRef idx="2">
-            <a:schemeClr val="accent1"/>
-          </a:effectRef>
-          <a:fontRef idx="minor">
-            <a:schemeClr val="lt1"/>
-          </a:fontRef>
-        </p:style>
-        <p:txBody>
-          <a:bodyPr rtlCol="0" anchor="ctr" wrap="square" lIns="101600" rIns="101600" tIns="50800" bIns="50800"/>
-          <a:lstStyle/>
-          <a:p>
-            <a:pPr algn="ctr"/>
-            <a:r>
-              <a:rPr sz="1050" b="1">
-                <a:solidFill>
-                  <a:srgbClr val="0B1F3A"/>
-                </a:solidFill>
-                <a:latin typeface="Segoe UI Semibold"/>
-              </a:rPr>
-              <a:t>Après rewrite</a:t>
-            </a:r>
-          </a:p>
-          <a:p>
-            <a:pPr algn="ctr"/>
-            <a:r>
-              <a:rPr sz="850">
-                <a:solidFill>
-                  <a:srgbClr val="5B6677"/>
-                </a:solidFill>
-                <a:latin typeface="Segoe UI"/>
-              </a:rPr>
-              <a:t>RAGAS sur entry['chunks']
-(pool final fusionné, gemma2:2b juge)</a:t>
-            </a:r>
-          </a:p>
-        </p:txBody>
-      </p:sp>
-      <p:cxnSp>
-        <p:nvCxnSpPr>
-          <p:cNvPr id="13" name="Connector 12"/>
-          <p:cNvCxnSpPr/>
-          <p:nvPr/>
-        </p:nvCxnSpPr>
-        <p:spPr>
-          <a:xfrm>
-            <a:off x="5852160" y="2514600"/>
-            <a:ext cx="0" cy="274320"/>
-          </a:xfrm>
-          <a:prstGeom prst="line">
-            <a:avLst/>
-          </a:prstGeom>
-          <a:ln w="28575">
-            <a:solidFill>
-              <a:srgbClr val="1B8A80"/>
-            </a:solidFill>
-            <a:tailEnd type="triangle" w="med" len="med"/>
-          </a:ln>
-          <a:effectLst/>
-        </p:spPr>
-        <p:style>
-          <a:lnRef idx="2">
-            <a:schemeClr val="accent1"/>
-          </a:lnRef>
-          <a:fillRef idx="0">
-            <a:schemeClr val="accent1"/>
-          </a:fillRef>
-          <a:effectRef idx="1">
-            <a:schemeClr val="accent1"/>
-          </a:effectRef>
-          <a:fontRef idx="minor">
-            <a:schemeClr val="tx1"/>
-          </a:fontRef>
-        </p:style>
-      </p:cxnSp>
-      <p:cxnSp>
-        <p:nvCxnSpPr>
-          <p:cNvPr id="14" name="Connector 13"/>
-          <p:cNvCxnSpPr/>
-          <p:nvPr/>
-        </p:nvCxnSpPr>
-        <p:spPr>
-          <a:xfrm>
-            <a:off x="9784080" y="2514600"/>
-            <a:ext cx="0" cy="274320"/>
-          </a:xfrm>
-          <a:prstGeom prst="line">
-            <a:avLst/>
-          </a:prstGeom>
-          <a:ln w="28575">
-            <a:solidFill>
-              <a:srgbClr val="1B8A80"/>
-            </a:solidFill>
-            <a:tailEnd type="triangle" w="med" len="med"/>
-          </a:ln>
-          <a:effectLst/>
-        </p:spPr>
-        <p:style>
-          <a:lnRef idx="2">
-            <a:schemeClr val="accent1"/>
-          </a:lnRef>
-          <a:fillRef idx="0">
-            <a:schemeClr val="accent1"/>
-          </a:fillRef>
-          <a:effectRef idx="1">
-            <a:schemeClr val="accent1"/>
-          </a:effectRef>
-          <a:fontRef idx="minor">
-            <a:schemeClr val="tx1"/>
-          </a:fontRef>
-        </p:style>
-      </p:cxnSp>
-      <p:sp>
-        <p:nvSpPr>
-          <p:cNvPr id="15" name="Rounded Rectangle 14"/>
-          <p:cNvSpPr/>
-          <p:nvPr/>
-        </p:nvSpPr>
-        <p:spPr>
-          <a:xfrm>
-            <a:off x="4023360" y="2788920"/>
-            <a:ext cx="7635240" cy="868680"/>
-          </a:xfrm>
-          <a:prstGeom prst="roundRect">
-            <a:avLst>
-              <a:gd name="adj" fmla="val 10000"/>
-            </a:avLst>
-          </a:prstGeom>
-          <a:solidFill>
-            <a:srgbClr val="FFFFFF"/>
-          </a:solidFill>
-          <a:ln w="22225">
-            <a:solidFill>
-              <a:srgbClr val="FF6B35"/>
-            </a:solidFill>
-          </a:ln>
-          <a:effectLst/>
-        </p:spPr>
-        <p:style>
-          <a:lnRef idx="1">
-            <a:schemeClr val="accent1"/>
-          </a:lnRef>
-          <a:fillRef idx="3">
-            <a:schemeClr val="accent1"/>
-          </a:fillRef>
-          <a:effectRef idx="2">
-            <a:schemeClr val="accent1"/>
-          </a:effectRef>
-          <a:fontRef idx="minor">
-            <a:schemeClr val="lt1"/>
-          </a:fontRef>
-        </p:style>
-        <p:txBody>
-          <a:bodyPr rtlCol="0" anchor="ctr" wrap="square" lIns="101600" rIns="101600" tIns="50800" bIns="50800"/>
-          <a:lstStyle/>
-          <a:p>
-            <a:pPr algn="ctr"/>
-            <a:r>
-              <a:rPr sz="1000" b="1">
-                <a:solidFill>
-                  <a:srgbClr val="0B1F3A"/>
-                </a:solidFill>
-                <a:latin typeface="Segoe UI Semibold"/>
-              </a:rPr>
-              <a:t>Le pool final = vrai mécanisme de fusion du pipeline</a:t>
-            </a:r>
-          </a:p>
-          <a:p>
-            <a:pPr algn="ctr"/>
-            <a:r>
-              <a:rPr sz="850">
-                <a:solidFill>
-                  <a:srgbClr val="5B6677"/>
-                </a:solidFill>
-                <a:latin typeface="Segoe UI"/>
-              </a:rPr>
-              <a:t>3 slots → meilleurs chunks du 1er retrieval  +  2 slots → top 2 des nouveaux chunks re-rankés sur la requête reformulée</a:t>
-            </a:r>
-          </a:p>
-        </p:txBody>
-      </p:sp>
-      <p:cxnSp>
-        <p:nvCxnSpPr>
-          <p:cNvPr id="16" name="Connector 15"/>
-          <p:cNvCxnSpPr/>
-          <p:nvPr/>
-        </p:nvCxnSpPr>
-        <p:spPr>
-          <a:xfrm>
-            <a:off x="7863840" y="3657600"/>
-            <a:ext cx="0" cy="274320"/>
-          </a:xfrm>
-          <a:prstGeom prst="line">
-            <a:avLst/>
-          </a:prstGeom>
-          <a:ln w="28575">
-            <a:solidFill>
-              <a:srgbClr val="1B8A80"/>
-            </a:solidFill>
-            <a:tailEnd type="triangle" w="med" len="med"/>
-          </a:ln>
-          <a:effectLst/>
-        </p:spPr>
-        <p:style>
-          <a:lnRef idx="2">
-            <a:schemeClr val="accent1"/>
-          </a:lnRef>
-          <a:fillRef idx="0">
-            <a:schemeClr val="accent1"/>
-          </a:fillRef>
-          <a:effectRef idx="1">
-            <a:schemeClr val="accent1"/>
-          </a:effectRef>
-          <a:fontRef idx="minor">
-            <a:schemeClr val="tx1"/>
-          </a:fontRef>
-        </p:style>
-      </p:cxnSp>
-      <p:sp>
-        <p:nvSpPr>
-          <p:cNvPr id="17" name="Rounded Rectangle 16"/>
-          <p:cNvSpPr/>
-          <p:nvPr/>
-        </p:nvSpPr>
-        <p:spPr>
-          <a:xfrm>
-            <a:off x="4023360" y="3931920"/>
-            <a:ext cx="7635240" cy="777240"/>
-          </a:xfrm>
-          <a:prstGeom prst="roundRect">
-            <a:avLst>
-              <a:gd name="adj" fmla="val 13000"/>
-            </a:avLst>
-          </a:prstGeom>
-          <a:solidFill>
-            <a:srgbClr val="0B1F3A"/>
-          </a:solidFill>
-          <a:ln>
-            <a:noFill/>
-          </a:ln>
-          <a:effectLst/>
-        </p:spPr>
-        <p:style>
-          <a:lnRef idx="1">
-            <a:schemeClr val="accent1"/>
-          </a:lnRef>
-          <a:fillRef idx="3">
-            <a:schemeClr val="accent1"/>
-          </a:fillRef>
-          <a:effectRef idx="2">
-            <a:schemeClr val="accent1"/>
-          </a:effectRef>
-          <a:fontRef idx="minor">
-            <a:schemeClr val="lt1"/>
-          </a:fontRef>
-        </p:style>
-        <p:txBody>
-          <a:bodyPr rtlCol="0" anchor="ctr"/>
-          <a:lstStyle/>
-          <a:p>
-            <a:pPr algn="ctr"/>
-          </a:p>
-        </p:txBody>
-      </p:sp>
-      <p:sp>
-        <p:nvSpPr>
-          <p:cNvPr id="18" name="TextBox 17"/>
-          <p:cNvSpPr txBox="1"/>
-          <p:nvPr/>
-        </p:nvSpPr>
-        <p:spPr>
-          <a:xfrm>
-            <a:off x="4251960" y="4023360"/>
-            <a:ext cx="7223760" cy="274320"/>
-          </a:xfrm>
-          <a:prstGeom prst="rect">
-            <a:avLst/>
-          </a:prstGeom>
-          <a:noFill/>
-        </p:spPr>
-        <p:txBody>
-          <a:bodyPr wrap="square" anchor="t" lIns="0" rIns="0" tIns="0" bIns="0">
-            <a:spAutoFit/>
-          </a:bodyPr>
-          <a:lstStyle/>
-          <a:p>
-            <a:pPr algn="l">
-              <a:lnSpc>
-                <a:spcPct val="100000"/>
-              </a:lnSpc>
-            </a:pPr>
-            <a:r>
-              <a:rPr sz="1050" b="1" i="0">
-                <a:solidFill>
-                  <a:srgbClr val="FFFFFF"/>
-                </a:solidFill>
-                <a:latin typeface="Segoe UI Semibold"/>
-              </a:rPr>
-              <a:t>rewrite_precision_gain = après − baseline   ·   rewrite_recall_gain = après − baseline</a:t>
-            </a:r>
-          </a:p>
-        </p:txBody>
-      </p:sp>
-      <p:sp>
-        <p:nvSpPr>
-          <p:cNvPr id="19" name="TextBox 18"/>
-          <p:cNvSpPr txBox="1"/>
-          <p:nvPr/>
-        </p:nvSpPr>
-        <p:spPr>
-          <a:xfrm>
-            <a:off x="4251960" y="4334256"/>
-            <a:ext cx="7223760" cy="274320"/>
-          </a:xfrm>
-          <a:prstGeom prst="rect">
-            <a:avLst/>
-          </a:prstGeom>
-          <a:noFill/>
-        </p:spPr>
-        <p:txBody>
-          <a:bodyPr wrap="square" anchor="t" lIns="0" rIns="0" tIns="0" bIns="0">
-            <a:spAutoFit/>
-          </a:bodyPr>
-          <a:lstStyle/>
-          <a:p>
-            <a:pPr algn="l">
-              <a:lnSpc>
-                <a:spcPct val="100000"/>
-              </a:lnSpc>
-            </a:pPr>
-            <a:r>
-              <a:rPr sz="1000" b="0" i="0">
-                <a:solidFill>
-                  <a:srgbClr val="C9D6E6"/>
-                </a:solidFill>
-                <a:latin typeface="Segoe UI"/>
-              </a:rPr>
-              <a:t>Mesuré : précision 85.4% (+0.7 pt en moyenne)  ·  rappel 90.9% (−4.7 pt en moyenne)</a:t>
-            </a:r>
-          </a:p>
-        </p:txBody>
-      </p:sp>
-      <p:sp>
-        <p:nvSpPr>
-          <p:cNvPr id="20" name="Rounded Rectangle 19"/>
-          <p:cNvSpPr/>
-          <p:nvPr/>
-        </p:nvSpPr>
-        <p:spPr>
-          <a:xfrm>
-            <a:off x="502920" y="4983480"/>
-            <a:ext cx="11201400" cy="1280160"/>
+            <a:off x="502920" y="1234440"/>
+            <a:ext cx="3623928" cy="4400000"/>
           </a:xfrm>
           <a:prstGeom prst="roundRect">
             <a:avLst>
@@ -27974,14 +27414,14 @@
       </p:sp>
       <p:sp>
         <p:nvSpPr>
-          <p:cNvPr id="21" name="Rectangle 20"/>
+          <p:cNvPr id="28" name="Rectangle 20"/>
           <p:cNvSpPr/>
           <p:nvPr/>
         </p:nvSpPr>
         <p:spPr>
           <a:xfrm>
-            <a:off x="502920" y="4983480"/>
-            <a:ext cx="11201400" cy="45720"/>
+            <a:off x="502920" y="1234440"/>
+            <a:ext cx="3623928" cy="45720"/>
           </a:xfrm>
           <a:prstGeom prst="rect">
             <a:avLst/>
@@ -28018,14 +27458,14 @@
       </p:sp>
       <p:sp>
         <p:nvSpPr>
-          <p:cNvPr id="22" name="TextBox 21"/>
-          <p:cNvSpPr txBox="1"/>
-          <p:nvPr/>
-        </p:nvSpPr>
-        <p:spPr>
-          <a:xfrm>
-            <a:off x="685800" y="5111496"/>
-            <a:ext cx="10835640" cy="274320"/>
+          <p:cNvPr id="29" name="TextBox 21"/>
+          <p:cNvSpPr txBox="1"/>
+          <p:nvPr/>
+        </p:nvSpPr>
+        <p:spPr>
+          <a:xfrm>
+            <a:off x="685800" y="1362456"/>
+            <a:ext cx="3258168" cy="274320"/>
           </a:xfrm>
           <a:prstGeom prst="rect">
             <a:avLst/>
@@ -28050,21 +27490,21 @@
                 </a:solidFill>
                 <a:latin typeface="Segoe UI Semibold"/>
               </a:rPr>
-              <a:t>Ce que cette brique mesure vraiment</a:t>
-            </a:r>
-          </a:p>
-        </p:txBody>
-      </p:sp>
-      <p:sp>
-        <p:nvSpPr>
-          <p:cNvPr id="23" name="TextBox 22"/>
-          <p:cNvSpPr txBox="1"/>
-          <p:nvPr/>
-        </p:nvSpPr>
-        <p:spPr>
-          <a:xfrm>
-            <a:off x="685800" y="5440680"/>
-            <a:ext cx="10835640" cy="731520"/>
+              <a:t>① RAGAS — Gain Precision / Recall</a:t>
+            </a:r>
+          </a:p>
+        </p:txBody>
+      </p:sp>
+      <p:sp>
+        <p:nvSpPr>
+          <p:cNvPr id="30" name="TextBox 22"/>
+          <p:cNvSpPr txBox="1"/>
+          <p:nvPr/>
+        </p:nvSpPr>
+        <p:spPr>
+          <a:xfrm>
+            <a:off x="685800" y="1691640"/>
+            <a:ext cx="3258168" cy="3842800"/>
           </a:xfrm>
           <a:prstGeom prst="rect">
             <a:avLst/>
@@ -28101,7 +27541,7 @@
                 </a:solidFill>
                 <a:latin typeface="Segoe UI"/>
               </a:rPr>
-              <a:t>Pas juste « la reformulation sonne mieux » — mais le retrieval a-t-il concrètement rapporté plus d'info pertinente ?</a:t>
+              <a:t>Baseline (avant rewrite) : scores déjà calculés à la brique ② (retrieval_ctx_precision/recall) — 0 appel LLM supplémentaire</a:t>
             </a:r>
           </a:p>
           <a:p>
@@ -28129,7 +27569,7 @@
                 </a:solidFill>
                 <a:latin typeface="Segoe UI"/>
               </a:rPr>
-              <a:t>La baseline n'est pas recalculée (0 appel LLM supplémentaire) — réutilisée depuis la brique ②</a:t>
+              <a:t>Après rewrite : RAGAS (gemma2:2b juge) sur entry['chunks'], le pool final fusionné</a:t>
             </a:r>
           </a:p>
           <a:p>
@@ -28157,161 +27597,75 @@
                 </a:solidFill>
                 <a:latin typeface="Segoe UI"/>
               </a:rPr>
-              <a:t>Le pool « après » est exactement celui produit par le vrai pipeline, pas reconstruit artificiellement</a:t>
-            </a:r>
-          </a:p>
-          <a:p>
-            <a:pPr>
-              <a:lnSpc>
-                <a:spcPct val="108000"/>
-              </a:lnSpc>
-              <a:spcAft>
-                <a:spcPts val="400"/>
-              </a:spcAft>
-            </a:pPr>
-            <a:r>
-              <a:rPr sz="930" b="1">
-                <a:solidFill>
-                  <a:srgbClr val="8A5CF6"/>
-                </a:solidFill>
-                <a:latin typeface="Segoe UI"/>
-              </a:rPr>
-              <a:t>—  </a:t>
-            </a:r>
-            <a:r>
-              <a:rPr sz="930">
-                <a:solidFill>
-                  <a:srgbClr val="1B1F27"/>
-                </a:solidFill>
-                <a:latin typeface="Segoe UI"/>
-              </a:rPr>
-              <a:t>Taux de réussite (rewrite_success) : le grading final dit-il OUI après rewrite ? Et nouveaux chunks utiles (rewrite_new_ratio) : part des chunks apportés par la reformulation jugés pertinents par le LLM-juge</a:t>
-            </a:r>
-          </a:p>
-          <a:p>
-            <a:pPr>
-              <a:lnSpc>
-                <a:spcPct val="108000"/>
-              </a:lnSpc>
-              <a:spcAft>
-                <a:spcPts val="400"/>
-              </a:spcAft>
-            </a:pPr>
-            <a:r>
-              <a:rPr sz="930" b="1">
-                <a:solidFill>
-                  <a:srgbClr val="8A5CF6"/>
-                </a:solidFill>
-                <a:latin typeface="Segoe UI"/>
-              </a:rPr>
-              <a:t>—  </a:t>
-            </a:r>
-            <a:r>
-              <a:rPr sz="930">
-                <a:solidFill>
-                  <a:srgbClr val="1B1F27"/>
-                </a:solidFill>
-                <a:latin typeface="Segoe UI"/>
-              </a:rPr>
-              <a:t>Ciblage (rewrite_targeted) : un LLM-juge vérifie si la nouvelle requête vise bien l'information manquante identifiée par le grading qui a déclenché la reformulation</a:t>
-            </a:r>
-          </a:p>
-        </p:txBody>
-      </p:sp>
-      <p:sp>
-        <p:nvSpPr>
-          <p:cNvPr id="24" name="TextBox 23"/>
-          <p:cNvSpPr txBox="1"/>
-          <p:nvPr/>
-        </p:nvSpPr>
-        <p:spPr>
-          <a:xfrm>
-            <a:off x="502920" y="6547104"/>
-            <a:ext cx="3657600" cy="274320"/>
-          </a:xfrm>
-          <a:prstGeom prst="rect">
-            <a:avLst/>
-          </a:prstGeom>
-          <a:noFill/>
-        </p:spPr>
-        <p:txBody>
-          <a:bodyPr wrap="square" anchor="t" lIns="0" rIns="0" tIns="0" bIns="0">
-            <a:spAutoFit/>
-          </a:bodyPr>
-          <a:lstStyle/>
-          <a:p>
-            <a:pPr algn="l">
-              <a:lnSpc>
-                <a:spcPct val="100000"/>
-              </a:lnSpc>
-            </a:pPr>
-            <a:r>
-              <a:rPr sz="900" b="0" i="0">
-                <a:solidFill>
-                  <a:srgbClr val="5B6677"/>
-                </a:solidFill>
-                <a:latin typeface="Segoe UI"/>
-              </a:rPr>
-              <a:t>RAG Aquila — Système RAG Agentique</a:t>
-            </a:r>
-          </a:p>
-        </p:txBody>
-      </p:sp>
-      <p:sp>
-        <p:nvSpPr>
-          <p:cNvPr id="25" name="TextBox 24"/>
-          <p:cNvSpPr txBox="1"/>
-          <p:nvPr/>
-        </p:nvSpPr>
-        <p:spPr>
-          <a:xfrm>
-            <a:off x="10972800" y="6547104"/>
-            <a:ext cx="731520" cy="274320"/>
-          </a:xfrm>
-          <a:prstGeom prst="rect">
-            <a:avLst/>
-          </a:prstGeom>
-          <a:noFill/>
-        </p:spPr>
-        <p:txBody>
-          <a:bodyPr wrap="square" anchor="t" lIns="0" rIns="0" tIns="0" bIns="0">
-            <a:spAutoFit/>
-          </a:bodyPr>
-          <a:lstStyle/>
-          <a:p>
-            <a:pPr algn="r">
-              <a:lnSpc>
-                <a:spcPct val="100000"/>
-              </a:lnSpc>
-            </a:pPr>
-            <a:r>
-              <a:rPr sz="900" b="0" i="0">
-                <a:solidFill>
-                  <a:srgbClr val="5B6677"/>
-                </a:solidFill>
-                <a:latin typeface="Segoe UI"/>
-              </a:rPr>
-              <a:t>22/32</a:t>
-            </a:r>
-          </a:p>
-        </p:txBody>
-      </p:sp>
-      <p:sp>
-        <p:nvSpPr>
-          <p:cNvPr id="26" name="Rectangle 25"/>
+              <a:t>rewrite_precision_gain / rewrite_recall_gain = après − baseline (positif = la reformulation a concrètement amélioré le retrieval)</a:t>
+            </a:r>
+          </a:p>
+        </p:txBody>
+      </p:sp>
+      <p:sp>
+        <p:nvSpPr>
+          <p:cNvPr id="31" name="Rounded Rectangle 19"/>
           <p:cNvSpPr/>
           <p:nvPr/>
         </p:nvSpPr>
         <p:spPr>
           <a:xfrm>
-            <a:off x="0" y="6492240"/>
-            <a:ext cx="12191695" cy="9525"/>
-          </a:xfrm>
-          <a:prstGeom prst="rect">
-            <a:avLst/>
+            <a:off x="4291656" y="1234440"/>
+            <a:ext cx="3623928" cy="4400000"/>
+          </a:xfrm>
+          <a:prstGeom prst="roundRect">
+            <a:avLst>
+              <a:gd name="adj" fmla="val 7000"/>
+            </a:avLst>
           </a:prstGeom>
           <a:solidFill>
-            <a:srgbClr val="E3E8EE"/>
+            <a:srgbClr val="FFFFFF"/>
+          </a:solidFill>
+          <a:ln w="12700">
+            <a:solidFill>
+              <a:srgbClr val="E3E8EE"/>
+            </a:solidFill>
+          </a:ln>
+          <a:effectLst/>
+        </p:spPr>
+        <p:style>
+          <a:lnRef idx="1">
+            <a:schemeClr val="accent1"/>
+          </a:lnRef>
+          <a:fillRef idx="3">
+            <a:schemeClr val="accent1"/>
+          </a:fillRef>
+          <a:effectRef idx="2">
+            <a:schemeClr val="accent1"/>
+          </a:effectRef>
+          <a:fontRef idx="minor">
+            <a:schemeClr val="lt1"/>
+          </a:fontRef>
+        </p:style>
+        <p:txBody>
+          <a:bodyPr rtlCol="0" anchor="ctr"/>
+          <a:lstStyle/>
+          <a:p>
+            <a:pPr algn="ctr"/>
+          </a:p>
+        </p:txBody>
+      </p:sp>
+      <p:sp>
+        <p:nvSpPr>
+          <p:cNvPr id="32" name="Rectangle 20"/>
+          <p:cNvSpPr/>
+          <p:nvPr/>
+        </p:nvSpPr>
+        <p:spPr>
+          <a:xfrm>
+            <a:off x="4291656" y="1234440"/>
+            <a:ext cx="3623928" cy="45720"/>
+          </a:xfrm>
+          <a:prstGeom prst="rect">
+            <a:avLst/>
+          </a:prstGeom>
+          <a:solidFill>
+            <a:srgbClr val="8A5CF6"/>
           </a:solidFill>
           <a:ln>
             <a:noFill/>
@@ -28337,6 +27691,390 @@
           <a:lstStyle/>
           <a:p>
             <a:pPr algn="ctr"/>
+          </a:p>
+        </p:txBody>
+      </p:sp>
+      <p:sp>
+        <p:nvSpPr>
+          <p:cNvPr id="33" name="TextBox 21"/>
+          <p:cNvSpPr txBox="1"/>
+          <p:nvPr/>
+        </p:nvSpPr>
+        <p:spPr>
+          <a:xfrm>
+            <a:off x="4474536" y="1362456"/>
+            <a:ext cx="3258168" cy="274320"/>
+          </a:xfrm>
+          <a:prstGeom prst="rect">
+            <a:avLst/>
+          </a:prstGeom>
+          <a:noFill/>
+        </p:spPr>
+        <p:txBody>
+          <a:bodyPr wrap="square" anchor="t" lIns="0" rIns="0" tIns="0" bIns="0">
+            <a:spAutoFit/>
+          </a:bodyPr>
+          <a:lstStyle/>
+          <a:p>
+            <a:pPr algn="l">
+              <a:lnSpc>
+                <a:spcPct val="100000"/>
+              </a:lnSpc>
+            </a:pPr>
+            <a:r>
+              <a:rPr sz="1150" b="1" i="0">
+                <a:solidFill>
+                  <a:srgbClr val="0B1F3A"/>
+                </a:solidFill>
+                <a:latin typeface="Segoe UI Semibold"/>
+              </a:rPr>
+              <a:t>② Sufficient après la 2ᵉ boucle</a:t>
+            </a:r>
+          </a:p>
+        </p:txBody>
+      </p:sp>
+      <p:sp>
+        <p:nvSpPr>
+          <p:cNvPr id="34" name="TextBox 22"/>
+          <p:cNvSpPr txBox="1"/>
+          <p:nvPr/>
+        </p:nvSpPr>
+        <p:spPr>
+          <a:xfrm>
+            <a:off x="4474536" y="1691640"/>
+            <a:ext cx="3258168" cy="3842800"/>
+          </a:xfrm>
+          <a:prstGeom prst="rect">
+            <a:avLst/>
+          </a:prstGeom>
+          <a:noFill/>
+        </p:spPr>
+        <p:txBody>
+          <a:bodyPr wrap="square" lIns="0" rIns="0" tIns="0" bIns="0">
+            <a:spAutoFit/>
+          </a:bodyPr>
+          <a:lstStyle/>
+          <a:p>
+            <a:pPr>
+              <a:lnSpc>
+                <a:spcPct val="108000"/>
+              </a:lnSpc>
+              <a:spcAft>
+                <a:spcPts val="400"/>
+              </a:spcAft>
+            </a:pPr>
+            <a:r>
+              <a:rPr sz="930" b="1">
+                <a:solidFill>
+                  <a:srgbClr val="8A5CF6"/>
+                </a:solidFill>
+                <a:latin typeface="Segoe UI"/>
+              </a:rPr>
+              <a:t>—  </a:t>
+            </a:r>
+            <a:r>
+              <a:rPr sz="930">
+                <a:solidFill>
+                  <a:srgbClr val="1B1F27"/>
+                </a:solidFill>
+                <a:latin typeface="Segoe UI"/>
+              </a:rPr>
+              <a:t>Grading final exécuté sur le pool POST-rewrite — rewrite['grading_after']['sufficient']</a:t>
+            </a:r>
+          </a:p>
+          <a:p>
+            <a:pPr>
+              <a:lnSpc>
+                <a:spcPct val="108000"/>
+              </a:lnSpc>
+              <a:spcAft>
+                <a:spcPts val="400"/>
+              </a:spcAft>
+            </a:pPr>
+            <a:r>
+              <a:rPr sz="930" b="1">
+                <a:solidFill>
+                  <a:srgbClr val="8A5CF6"/>
+                </a:solidFill>
+                <a:latin typeface="Segoe UI"/>
+              </a:rPr>
+              <a:t>—  </a:t>
+            </a:r>
+            <a:r>
+              <a:rPr sz="930">
+                <a:solidFill>
+                  <a:srgbClr val="1B1F27"/>
+                </a:solidFill>
+                <a:latin typeface="Segoe UI"/>
+              </a:rPr>
+              <a:t>sufficient = True → la reformulation a comblé le manque identifié par le grading initial</a:t>
+            </a:r>
+          </a:p>
+          <a:p>
+            <a:pPr>
+              <a:lnSpc>
+                <a:spcPct val="108000"/>
+              </a:lnSpc>
+              <a:spcAft>
+                <a:spcPts val="400"/>
+              </a:spcAft>
+            </a:pPr>
+            <a:r>
+              <a:rPr sz="930" b="1">
+                <a:solidFill>
+                  <a:srgbClr val="8A5CF6"/>
+                </a:solidFill>
+                <a:latin typeface="Segoe UI"/>
+              </a:rPr>
+              <a:t>—  </a:t>
+            </a:r>
+            <a:r>
+              <a:rPr sz="930">
+                <a:solidFill>
+                  <a:srgbClr val="1B1F27"/>
+                </a:solidFill>
+                <a:latin typeface="Segoe UI"/>
+              </a:rPr>
+              <a:t>sufficient = False → rewrite_success = 0 : le manque persiste malgré la reformulation</a:t>
+            </a:r>
+          </a:p>
+        </p:txBody>
+      </p:sp>
+      <p:sp>
+        <p:nvSpPr>
+          <p:cNvPr id="35" name="Rounded Rectangle 19"/>
+          <p:cNvSpPr/>
+          <p:nvPr/>
+        </p:nvSpPr>
+        <p:spPr>
+          <a:xfrm>
+            <a:off x="8080392" y="1234440"/>
+            <a:ext cx="3623928" cy="4400000"/>
+          </a:xfrm>
+          <a:prstGeom prst="roundRect">
+            <a:avLst>
+              <a:gd name="adj" fmla="val 7000"/>
+            </a:avLst>
+          </a:prstGeom>
+          <a:solidFill>
+            <a:srgbClr val="FFFFFF"/>
+          </a:solidFill>
+          <a:ln w="12700">
+            <a:solidFill>
+              <a:srgbClr val="E3E8EE"/>
+            </a:solidFill>
+          </a:ln>
+          <a:effectLst/>
+        </p:spPr>
+        <p:style>
+          <a:lnRef idx="1">
+            <a:schemeClr val="accent1"/>
+          </a:lnRef>
+          <a:fillRef idx="3">
+            <a:schemeClr val="accent1"/>
+          </a:fillRef>
+          <a:effectRef idx="2">
+            <a:schemeClr val="accent1"/>
+          </a:effectRef>
+          <a:fontRef idx="minor">
+            <a:schemeClr val="lt1"/>
+          </a:fontRef>
+        </p:style>
+        <p:txBody>
+          <a:bodyPr rtlCol="0" anchor="ctr"/>
+          <a:lstStyle/>
+          <a:p>
+            <a:pPr algn="ctr"/>
+          </a:p>
+        </p:txBody>
+      </p:sp>
+      <p:sp>
+        <p:nvSpPr>
+          <p:cNvPr id="36" name="Rectangle 20"/>
+          <p:cNvSpPr/>
+          <p:nvPr/>
+        </p:nvSpPr>
+        <p:spPr>
+          <a:xfrm>
+            <a:off x="8080392" y="1234440"/>
+            <a:ext cx="3623928" cy="45720"/>
+          </a:xfrm>
+          <a:prstGeom prst="rect">
+            <a:avLst/>
+          </a:prstGeom>
+          <a:solidFill>
+            <a:srgbClr val="8A5CF6"/>
+          </a:solidFill>
+          <a:ln>
+            <a:noFill/>
+          </a:ln>
+          <a:effectLst/>
+        </p:spPr>
+        <p:style>
+          <a:lnRef idx="1">
+            <a:schemeClr val="accent1"/>
+          </a:lnRef>
+          <a:fillRef idx="3">
+            <a:schemeClr val="accent1"/>
+          </a:fillRef>
+          <a:effectRef idx="2">
+            <a:schemeClr val="accent1"/>
+          </a:effectRef>
+          <a:fontRef idx="minor">
+            <a:schemeClr val="lt1"/>
+          </a:fontRef>
+        </p:style>
+        <p:txBody>
+          <a:bodyPr rtlCol="0" anchor="ctr"/>
+          <a:lstStyle/>
+          <a:p>
+            <a:pPr algn="ctr"/>
+          </a:p>
+        </p:txBody>
+      </p:sp>
+      <p:sp>
+        <p:nvSpPr>
+          <p:cNvPr id="37" name="TextBox 21"/>
+          <p:cNvSpPr txBox="1"/>
+          <p:nvPr/>
+        </p:nvSpPr>
+        <p:spPr>
+          <a:xfrm>
+            <a:off x="8263272" y="1362456"/>
+            <a:ext cx="3258168" cy="274320"/>
+          </a:xfrm>
+          <a:prstGeom prst="rect">
+            <a:avLst/>
+          </a:prstGeom>
+          <a:noFill/>
+        </p:spPr>
+        <p:txBody>
+          <a:bodyPr wrap="square" anchor="t" lIns="0" rIns="0" tIns="0" bIns="0">
+            <a:spAutoFit/>
+          </a:bodyPr>
+          <a:lstStyle/>
+          <a:p>
+            <a:pPr algn="l">
+              <a:lnSpc>
+                <a:spcPct val="100000"/>
+              </a:lnSpc>
+            </a:pPr>
+            <a:r>
+              <a:rPr sz="1150" b="1" i="0">
+                <a:solidFill>
+                  <a:srgbClr val="0B1F3A"/>
+                </a:solidFill>
+                <a:latin typeface="Segoe UI Semibold"/>
+              </a:rPr>
+              <a:t>③ Précision &amp; nouveauté des 2 derniers chunks</a:t>
+            </a:r>
+          </a:p>
+        </p:txBody>
+      </p:sp>
+      <p:sp>
+        <p:nvSpPr>
+          <p:cNvPr id="38" name="TextBox 22"/>
+          <p:cNvSpPr txBox="1"/>
+          <p:nvPr/>
+        </p:nvSpPr>
+        <p:spPr>
+          <a:xfrm>
+            <a:off x="8263272" y="1691640"/>
+            <a:ext cx="3258168" cy="3842800"/>
+          </a:xfrm>
+          <a:prstGeom prst="rect">
+            <a:avLst/>
+          </a:prstGeom>
+          <a:noFill/>
+        </p:spPr>
+        <p:txBody>
+          <a:bodyPr wrap="square" lIns="0" rIns="0" tIns="0" bIns="0">
+            <a:spAutoFit/>
+          </a:bodyPr>
+          <a:lstStyle/>
+          <a:p>
+            <a:pPr>
+              <a:lnSpc>
+                <a:spcPct val="108000"/>
+              </a:lnSpc>
+              <a:spcAft>
+                <a:spcPts val="400"/>
+              </a:spcAft>
+            </a:pPr>
+            <a:r>
+              <a:rPr sz="930" b="1">
+                <a:solidFill>
+                  <a:srgbClr val="8A5CF6"/>
+                </a:solidFill>
+                <a:latin typeface="Segoe UI"/>
+              </a:rPr>
+              <a:t>—  </a:t>
+            </a:r>
+            <a:r>
+              <a:rPr sz="930">
+                <a:solidFill>
+                  <a:srgbClr val="1B1F27"/>
+                </a:solidFill>
+                <a:latin typeface="Segoe UI"/>
+              </a:rPr>
+              <a:t>Pool final = 3 anciens chunks (meilleurs du 1er retrieval) + 2 nouveaux, re-rankés sur la requête reformulée</a:t>
+            </a:r>
+          </a:p>
+          <a:p>
+            <a:pPr>
+              <a:lnSpc>
+                <a:spcPct val="108000"/>
+              </a:lnSpc>
+              <a:spcAft>
+                <a:spcPts val="400"/>
+              </a:spcAft>
+            </a:pPr>
+            <a:r>
+              <a:rPr sz="930" b="1">
+                <a:solidFill>
+                  <a:srgbClr val="8A5CF6"/>
+                </a:solidFill>
+                <a:latin typeface="Segoe UI"/>
+              </a:rPr>
+              <a:t>—  </a:t>
+            </a:r>
+            <a:r>
+              <a:rPr sz="930">
+                <a:solidFill>
+                  <a:srgbClr val="1B1F27"/>
+                </a:solidFill>
+                <a:latin typeface="Segoe UI"/>
+              </a:rPr>
+              <a:t>Nouveauté : chunks de chunks_loop_2 absents de chunks_loop_1 → rewrite_n_new_chunks</a:t>
+            </a:r>
+          </a:p>
+          <a:p>
+            <a:pPr>
+              <a:lnSpc>
+                <a:spcPct val="108000"/>
+              </a:lnSpc>
+              <a:spcAft>
+                <a:spcPts val="400"/>
+              </a:spcAft>
+            </a:pPr>
+            <a:r>
+              <a:rPr sz="930" b="1">
+                <a:solidFill>
+                  <a:srgbClr val="8A5CF6"/>
+                </a:solidFill>
+                <a:latin typeface="Segoe UI"/>
+              </a:rPr>
+              <a:t>—  </a:t>
+            </a:r>
+            <a:r>
+              <a:rPr sz="930">
+                <a:solidFill>
+                  <a:srgbClr val="1B1F27"/>
+                </a:solidFill>
+                <a:latin typeface="Segoe UI"/>
+              </a:rPr>
+              <a:t>Précision : un LLM-juge labellise chaque nouveau chunk → rewrite_new_ratio = pertinents / nouveaux</a:t>
+            </a:r>
           </a:p>
         </p:txBody>
       </p:sp>
@@ -42372,7 +42110,7 @@
                 </a:solidFill>
                 <a:latin typeface="Segoe UI"/>
               </a:rPr>
-              <a:t>Total scoring estimé : ~750 à 2000 appels LLM pour les 50 questions</a:t>
+              <a:t>Total scoring estimé : ~900 appels LLM pour les 50 questions</a:t>
             </a:r>
           </a:p>
           <a:p>
@@ -45052,62 +44790,6 @@
             <a:spAutoFit/>
           </a:bodyPr>
           <a:lstStyle/>
-          <a:p>
-            <a:pPr>
-              <a:lnSpc>
-                <a:spcPct val="112000"/>
-              </a:lnSpc>
-              <a:spcAft>
-                <a:spcPts val="500"/>
-              </a:spcAft>
-            </a:pPr>
-            <a:r>
-              <a:rPr sz="1000" b="1">
-                <a:solidFill>
-                  <a:srgbClr val="E64A4A"/>
-                </a:solidFill>
-                <a:latin typeface="Segoe UI"/>
-              </a:rPr>
-              <a:t>—  </a:t>
-            </a:r>
-            <a:r>
-              <a:rPr sz="1000">
-                <a:solidFill>
-                  <a:srgbClr val="1B1F27"/>
-                </a:solidFill>
-                <a:latin typeface="Segoe UI"/>
-              </a:rPr>
-              <a:t>Routeur peu fiable sur l'identification de la source (58% de précision)</a:t>
-            </a:r>
-          </a:p>
-          <a:p>
-            <a:pPr>
-              <a:lnSpc>
-                <a:spcPct val="112000"/>
-              </a:lnSpc>
-              <a:spcAft>
-                <a:spcPts val="500"/>
-              </a:spcAft>
-            </a:pPr>
-            <a:r>
-              <a:rPr sz="1000" b="1">
-                <a:solidFill>
-                  <a:srgbClr val="E64A4A"/>
-                </a:solidFill>
-                <a:latin typeface="Segoe UI"/>
-              </a:rPr>
-              <a:t>—  </a:t>
-            </a:r>
-            <a:r>
-              <a:rPr sz="1000">
-                <a:solidFill>
-                  <a:srgbClr val="1B1F27"/>
-                </a:solidFill>
-                <a:latin typeface="Segoe UI"/>
-              </a:rPr>
-              <a:t>Grading parfois trop laxiste comparé à un juge externe</a:t>
-            </a:r>
-          </a:p>
           <a:p>
             <a:pPr>
               <a:lnSpc>

</xml_diff>